<commit_message>
TL02 Sim-Review: 8 VP + 6 VP-T eingearbeitet + sim_review true
Teilnehmer-Sim + Trainer-Trainability: Quiz-Reihenfolge, Selbstreflexion-
Ueberleitung, Grenz-Faustformel D2/Wertekonflikt, Ergebnisdruck-Einwand,
AB-1-Regieblock (1 Diagnose/D-Etikett/Energizer), Schritt-3-Sequenz,
AB-2-vs-Wissenstest, Kurvenform-Hinweis, D2-Frage-Exitpfad, Kuerzungslogik,
Prozesshinweis geschaerft. Workbook/Trainerhandbuch/Deck neu, Validator 0/0.

Co-Authored-By: Claude Opus 4.8 <noreply@anthropic.com>
</commit_message>
<xml_diff>
--- a/protected-downloads/praesentation/TL02.pptx
+++ b/protected-downloads/praesentation/TL02.pptx
@@ -667,6 +667,11 @@
         <p:txBody>
           <a:bodyPr/>
           <a:lstStyle/>
+          <a:p>
+            <a:r>
+              <a:t>Grenz-Faustformel (max. 2 Sätze, dann direkt zum Gesprächseinstieg): D2 zeigt sich in der Frageform ('Schaffe ich das?' – Zweifel am Können), Wertekonflikt in der Aussageform ('Das halte ich für falsch' – Ablehnung der Sache). Vertiefung nur auf Nachfrage.</a:t>
+            </a:r>
+          </a:p>
           <a:p>
             <a:r>
               <a:t>Trainer-Eröffnung von Marlies wörtlich vorlesen: 'Sigrid, ich schaue mir die Systemdaten der letzten zwei Wochen an…' – demonstriert den Tonraum zwischen Anklage und Entschuldigung.</a:t>
@@ -14098,7 +14103,7 @@
                 </a:solidFill>
                 <a:latin typeface="Arial"/>
               </a:rPr>
-              <a:t>  ·  Einzelarbeit, still (5–7 Min.): Selbstreflexionsfragen aus Sec 4 (Leitfragen 1–3). Kein Sammeln im Plenum – Ergebnis bleibt persönlich. Überleitung: „Was Sie jetzt aufgeschrieben haben, bringen Sie gleich in die Fallarbeit mit."</a:t>
+              <a:t>  ·  Einzelarbeit, still (5–7 Min.): Selbstreflexionsfragen aus Sec 4 (Leitfragen 1–3). Kein Sammeln im Plenum – Ergebnis bleibt persönlich. Überleitung: „Bitte lassen Sie das Formular offen – Sie brauchen Frage 4 gleich für die Fallberatung. Was Sie jetzt aufgeschrieben haben, bringen Sie gleich in die Fallarbeit mit."</a:t>
             </a:r>
           </a:p>
           <a:p>

</xml_diff>